<commit_message>
Add Bengali emergency support and update pitch deck
</commit_message>
<xml_diff>
--- a/neurocardiotwin/NeuroCardioTwin_Competition_Presentation.pptx
+++ b/neurocardiotwin/NeuroCardioTwin_Competition_Presentation.pptx
@@ -15,6 +15,7 @@
     <p:sldId id="263" r:id="rId14"/>
     <p:sldId id="264" r:id="rId15"/>
     <p:sldId id="265" r:id="rId16"/>
+    <p:sldId id="266" r:id="rId17"/>
   </p:sldIdLst>
   <p:sldSz cx="12191695" cy="6858000" type="screen4x3"/>
   <p:notesSz cx="6858000" cy="9144000"/>
@@ -3609,6 +3610,668 @@
       <p:grpSpPr/>
       <p:sp>
         <p:nvSpPr>
+          <p:cNvPr id="2" name="TextBox 1"/>
+          <p:cNvSpPr txBox="1"/>
+          <p:nvPr/>
+        </p:nvSpPr>
+        <p:spPr>
+          <a:xfrm>
+            <a:off x="566928" y="365760"/>
+            <a:ext cx="10789920" cy="237744"/>
+          </a:xfrm>
+          <a:prstGeom prst="rect">
+            <a:avLst/>
+          </a:prstGeom>
+          <a:noFill/>
+        </p:spPr>
+        <p:txBody>
+          <a:bodyPr wrap="square" anchor="t">
+            <a:spAutoFit/>
+          </a:bodyPr>
+          <a:lstStyle/>
+          <a:p>
+            <a:pPr>
+              <a:defRPr sz="900" b="1">
+                <a:solidFill>
+                  <a:srgbClr val="22D3EE"/>
+                </a:solidFill>
+                <a:latin typeface="Courier New"/>
+              </a:defRPr>
+            </a:pPr>
+            <a:r>
+              <a:t>IMPACT &amp; NEXT STEPS</a:t>
+            </a:r>
+          </a:p>
+        </p:txBody>
+      </p:sp>
+      <p:sp>
+        <p:nvSpPr>
+          <p:cNvPr id="3" name="TextBox 2"/>
+          <p:cNvSpPr txBox="1"/>
+          <p:nvPr/>
+        </p:nvSpPr>
+        <p:spPr>
+          <a:xfrm>
+            <a:off x="548640" y="658368"/>
+            <a:ext cx="10972800" cy="530352"/>
+          </a:xfrm>
+          <a:prstGeom prst="rect">
+            <a:avLst/>
+          </a:prstGeom>
+          <a:noFill/>
+        </p:spPr>
+        <p:txBody>
+          <a:bodyPr wrap="square" anchor="t">
+            <a:spAutoFit/>
+          </a:bodyPr>
+          <a:lstStyle/>
+          <a:p>
+            <a:pPr>
+              <a:defRPr sz="2700" b="1">
+                <a:solidFill>
+                  <a:srgbClr val="EDF6FF"/>
+                </a:solidFill>
+                <a:latin typeface="Aptos"/>
+              </a:defRPr>
+            </a:pPr>
+            <a:r>
+              <a:t>A platform designed to grow with the research community.</a:t>
+            </a:r>
+          </a:p>
+        </p:txBody>
+      </p:sp>
+      <p:sp>
+        <p:nvSpPr>
+          <p:cNvPr id="4" name="Rectangle 3"/>
+          <p:cNvSpPr/>
+          <p:nvPr/>
+        </p:nvSpPr>
+        <p:spPr>
+          <a:xfrm>
+            <a:off x="566928" y="1764792"/>
+            <a:ext cx="11064240" cy="18288"/>
+          </a:xfrm>
+          <a:prstGeom prst="rect">
+            <a:avLst/>
+          </a:prstGeom>
+          <a:solidFill>
+            <a:srgbClr val="305477"/>
+          </a:solidFill>
+          <a:ln>
+            <a:noFill/>
+          </a:ln>
+        </p:spPr>
+        <p:style>
+          <a:lnRef idx="1">
+            <a:schemeClr val="accent1"/>
+          </a:lnRef>
+          <a:fillRef idx="3">
+            <a:schemeClr val="accent1"/>
+          </a:fillRef>
+          <a:effectRef idx="2">
+            <a:schemeClr val="accent1"/>
+          </a:effectRef>
+          <a:fontRef idx="minor">
+            <a:schemeClr val="lt1"/>
+          </a:fontRef>
+        </p:style>
+        <p:txBody>
+          <a:bodyPr rtlCol="0" anchor="ctr"/>
+          <a:lstStyle/>
+          <a:p>
+            <a:pPr algn="ctr"/>
+          </a:p>
+        </p:txBody>
+      </p:sp>
+      <p:sp>
+        <p:nvSpPr>
+          <p:cNvPr id="5" name="TextBox 4"/>
+          <p:cNvSpPr txBox="1"/>
+          <p:nvPr/>
+        </p:nvSpPr>
+        <p:spPr>
+          <a:xfrm>
+            <a:off x="777240" y="2057400"/>
+            <a:ext cx="201168" cy="219456"/>
+          </a:xfrm>
+          <a:prstGeom prst="rect">
+            <a:avLst/>
+          </a:prstGeom>
+          <a:noFill/>
+        </p:spPr>
+        <p:txBody>
+          <a:bodyPr wrap="square" anchor="t">
+            <a:spAutoFit/>
+          </a:bodyPr>
+          <a:lstStyle/>
+          <a:p>
+            <a:pPr>
+              <a:defRPr sz="1000" b="0">
+                <a:solidFill>
+                  <a:srgbClr val="22D3EE"/>
+                </a:solidFill>
+                <a:latin typeface="Aptos"/>
+              </a:defRPr>
+            </a:pPr>
+            <a:r>
+              <a:t>●</a:t>
+            </a:r>
+          </a:p>
+        </p:txBody>
+      </p:sp>
+      <p:sp>
+        <p:nvSpPr>
+          <p:cNvPr id="6" name="TextBox 5"/>
+          <p:cNvSpPr txBox="1"/>
+          <p:nvPr/>
+        </p:nvSpPr>
+        <p:spPr>
+          <a:xfrm>
+            <a:off x="1033272" y="2043684"/>
+            <a:ext cx="6053328" cy="347472"/>
+          </a:xfrm>
+          <a:prstGeom prst="rect">
+            <a:avLst/>
+          </a:prstGeom>
+          <a:noFill/>
+        </p:spPr>
+        <p:txBody>
+          <a:bodyPr wrap="square" anchor="t">
+            <a:spAutoFit/>
+          </a:bodyPr>
+          <a:lstStyle/>
+          <a:p>
+            <a:pPr>
+              <a:defRPr sz="1400" b="0">
+                <a:solidFill>
+                  <a:srgbClr val="EDF6FF"/>
+                </a:solidFill>
+                <a:latin typeface="Aptos"/>
+              </a:defRPr>
+            </a:pPr>
+            <a:r>
+              <a:t>Pilot with supervised research teams using consented, de-identified signal datasets.</a:t>
+            </a:r>
+          </a:p>
+        </p:txBody>
+      </p:sp>
+      <p:sp>
+        <p:nvSpPr>
+          <p:cNvPr id="7" name="TextBox 6"/>
+          <p:cNvSpPr txBox="1"/>
+          <p:nvPr/>
+        </p:nvSpPr>
+        <p:spPr>
+          <a:xfrm>
+            <a:off x="777240" y="2679192"/>
+            <a:ext cx="201168" cy="219456"/>
+          </a:xfrm>
+          <a:prstGeom prst="rect">
+            <a:avLst/>
+          </a:prstGeom>
+          <a:noFill/>
+        </p:spPr>
+        <p:txBody>
+          <a:bodyPr wrap="square" anchor="t">
+            <a:spAutoFit/>
+          </a:bodyPr>
+          <a:lstStyle/>
+          <a:p>
+            <a:pPr>
+              <a:defRPr sz="1000" b="0">
+                <a:solidFill>
+                  <a:srgbClr val="22D3EE"/>
+                </a:solidFill>
+                <a:latin typeface="Aptos"/>
+              </a:defRPr>
+            </a:pPr>
+            <a:r>
+              <a:t>●</a:t>
+            </a:r>
+          </a:p>
+        </p:txBody>
+      </p:sp>
+      <p:sp>
+        <p:nvSpPr>
+          <p:cNvPr id="8" name="TextBox 7"/>
+          <p:cNvSpPr txBox="1"/>
+          <p:nvPr/>
+        </p:nvSpPr>
+        <p:spPr>
+          <a:xfrm>
+            <a:off x="1033272" y="2665476"/>
+            <a:ext cx="6053328" cy="347472"/>
+          </a:xfrm>
+          <a:prstGeom prst="rect">
+            <a:avLst/>
+          </a:prstGeom>
+          <a:noFill/>
+        </p:spPr>
+        <p:txBody>
+          <a:bodyPr wrap="square" anchor="t">
+            <a:spAutoFit/>
+          </a:bodyPr>
+          <a:lstStyle/>
+          <a:p>
+            <a:pPr>
+              <a:defRPr sz="1400" b="0">
+                <a:solidFill>
+                  <a:srgbClr val="EDF6FF"/>
+                </a:solidFill>
+                <a:latin typeface="Aptos"/>
+              </a:defRPr>
+            </a:pPr>
+            <a:r>
+              <a:t>Expand the approved knowledge base through clinician/researcher review workflows.</a:t>
+            </a:r>
+          </a:p>
+        </p:txBody>
+      </p:sp>
+      <p:sp>
+        <p:nvSpPr>
+          <p:cNvPr id="9" name="TextBox 8"/>
+          <p:cNvSpPr txBox="1"/>
+          <p:nvPr/>
+        </p:nvSpPr>
+        <p:spPr>
+          <a:xfrm>
+            <a:off x="777240" y="3300984"/>
+            <a:ext cx="201168" cy="219456"/>
+          </a:xfrm>
+          <a:prstGeom prst="rect">
+            <a:avLst/>
+          </a:prstGeom>
+          <a:noFill/>
+        </p:spPr>
+        <p:txBody>
+          <a:bodyPr wrap="square" anchor="t">
+            <a:spAutoFit/>
+          </a:bodyPr>
+          <a:lstStyle/>
+          <a:p>
+            <a:pPr>
+              <a:defRPr sz="1000" b="0">
+                <a:solidFill>
+                  <a:srgbClr val="22D3EE"/>
+                </a:solidFill>
+                <a:latin typeface="Aptos"/>
+              </a:defRPr>
+            </a:pPr>
+            <a:r>
+              <a:t>●</a:t>
+            </a:r>
+          </a:p>
+        </p:txBody>
+      </p:sp>
+      <p:sp>
+        <p:nvSpPr>
+          <p:cNvPr id="10" name="TextBox 9"/>
+          <p:cNvSpPr txBox="1"/>
+          <p:nvPr/>
+        </p:nvSpPr>
+        <p:spPr>
+          <a:xfrm>
+            <a:off x="1033272" y="3287268"/>
+            <a:ext cx="6053328" cy="347472"/>
+          </a:xfrm>
+          <a:prstGeom prst="rect">
+            <a:avLst/>
+          </a:prstGeom>
+          <a:noFill/>
+        </p:spPr>
+        <p:txBody>
+          <a:bodyPr wrap="square" anchor="t">
+            <a:spAutoFit/>
+          </a:bodyPr>
+          <a:lstStyle/>
+          <a:p>
+            <a:pPr>
+              <a:defRPr sz="1400" b="0">
+                <a:solidFill>
+                  <a:srgbClr val="EDF6FF"/>
+                </a:solidFill>
+                <a:latin typeface="Aptos"/>
+              </a:defRPr>
+            </a:pPr>
+            <a:r>
+              <a:t>Add calibrated model evaluation, cohort-level fairness analysis, and reproducible audit exports.</a:t>
+            </a:r>
+          </a:p>
+        </p:txBody>
+      </p:sp>
+      <p:sp>
+        <p:nvSpPr>
+          <p:cNvPr id="11" name="TextBox 10"/>
+          <p:cNvSpPr txBox="1"/>
+          <p:nvPr/>
+        </p:nvSpPr>
+        <p:spPr>
+          <a:xfrm>
+            <a:off x="777240" y="3922776"/>
+            <a:ext cx="201168" cy="219456"/>
+          </a:xfrm>
+          <a:prstGeom prst="rect">
+            <a:avLst/>
+          </a:prstGeom>
+          <a:noFill/>
+        </p:spPr>
+        <p:txBody>
+          <a:bodyPr wrap="square" anchor="t">
+            <a:spAutoFit/>
+          </a:bodyPr>
+          <a:lstStyle/>
+          <a:p>
+            <a:pPr>
+              <a:defRPr sz="1000" b="0">
+                <a:solidFill>
+                  <a:srgbClr val="22D3EE"/>
+                </a:solidFill>
+                <a:latin typeface="Aptos"/>
+              </a:defRPr>
+            </a:pPr>
+            <a:r>
+              <a:t>●</a:t>
+            </a:r>
+          </a:p>
+        </p:txBody>
+      </p:sp>
+      <p:sp>
+        <p:nvSpPr>
+          <p:cNvPr id="12" name="TextBox 11"/>
+          <p:cNvSpPr txBox="1"/>
+          <p:nvPr/>
+        </p:nvSpPr>
+        <p:spPr>
+          <a:xfrm>
+            <a:off x="1033272" y="3909060"/>
+            <a:ext cx="6053328" cy="347472"/>
+          </a:xfrm>
+          <a:prstGeom prst="rect">
+            <a:avLst/>
+          </a:prstGeom>
+          <a:noFill/>
+        </p:spPr>
+        <p:txBody>
+          <a:bodyPr wrap="square" anchor="t">
+            <a:spAutoFit/>
+          </a:bodyPr>
+          <a:lstStyle/>
+          <a:p>
+            <a:pPr>
+              <a:defRPr sz="1400" b="0">
+                <a:solidFill>
+                  <a:srgbClr val="EDF6FF"/>
+                </a:solidFill>
+                <a:latin typeface="Aptos"/>
+              </a:defRPr>
+            </a:pPr>
+            <a:r>
+              <a:t>Connect validated real-time devices only after robust signal-quality and governance testing.</a:t>
+            </a:r>
+          </a:p>
+        </p:txBody>
+      </p:sp>
+      <p:sp>
+        <p:nvSpPr>
+          <p:cNvPr id="13" name="Rounded Rectangle 12"/>
+          <p:cNvSpPr/>
+          <p:nvPr/>
+        </p:nvSpPr>
+        <p:spPr>
+          <a:xfrm>
+            <a:off x="7543800" y="2057400"/>
+            <a:ext cx="3657600" cy="3108960"/>
+          </a:xfrm>
+          <a:prstGeom prst="roundRect">
+            <a:avLst/>
+          </a:prstGeom>
+          <a:solidFill>
+            <a:srgbClr val="122740"/>
+          </a:solidFill>
+          <a:ln>
+            <a:solidFill>
+              <a:srgbClr val="315779"/>
+            </a:solidFill>
+          </a:ln>
+        </p:spPr>
+        <p:style>
+          <a:lnRef idx="1">
+            <a:schemeClr val="accent1"/>
+          </a:lnRef>
+          <a:fillRef idx="3">
+            <a:schemeClr val="accent1"/>
+          </a:fillRef>
+          <a:effectRef idx="2">
+            <a:schemeClr val="accent1"/>
+          </a:effectRef>
+          <a:fontRef idx="minor">
+            <a:schemeClr val="lt1"/>
+          </a:fontRef>
+        </p:style>
+        <p:txBody>
+          <a:bodyPr rtlCol="0" anchor="ctr"/>
+          <a:lstStyle/>
+          <a:p>
+            <a:pPr algn="ctr"/>
+          </a:p>
+        </p:txBody>
+      </p:sp>
+      <p:sp>
+        <p:nvSpPr>
+          <p:cNvPr id="14" name="TextBox 13"/>
+          <p:cNvSpPr txBox="1"/>
+          <p:nvPr/>
+        </p:nvSpPr>
+        <p:spPr>
+          <a:xfrm>
+            <a:off x="7818120" y="2350008"/>
+            <a:ext cx="1828800" cy="182880"/>
+          </a:xfrm>
+          <a:prstGeom prst="rect">
+            <a:avLst/>
+          </a:prstGeom>
+          <a:noFill/>
+        </p:spPr>
+        <p:txBody>
+          <a:bodyPr wrap="square" anchor="t">
+            <a:spAutoFit/>
+          </a:bodyPr>
+          <a:lstStyle/>
+          <a:p>
+            <a:pPr>
+              <a:defRPr sz="1000" b="1">
+                <a:solidFill>
+                  <a:srgbClr val="22D3EE"/>
+                </a:solidFill>
+                <a:latin typeface="Courier New"/>
+              </a:defRPr>
+            </a:pPr>
+            <a:r>
+              <a:t>VISION</a:t>
+            </a:r>
+          </a:p>
+        </p:txBody>
+      </p:sp>
+      <p:sp>
+        <p:nvSpPr>
+          <p:cNvPr id="15" name="TextBox 14"/>
+          <p:cNvSpPr txBox="1"/>
+          <p:nvPr/>
+        </p:nvSpPr>
+        <p:spPr>
+          <a:xfrm>
+            <a:off x="7818120" y="2798064"/>
+            <a:ext cx="2743200" cy="1143000"/>
+          </a:xfrm>
+          <a:prstGeom prst="rect">
+            <a:avLst/>
+          </a:prstGeom>
+          <a:noFill/>
+        </p:spPr>
+        <p:txBody>
+          <a:bodyPr wrap="square" anchor="t">
+            <a:spAutoFit/>
+          </a:bodyPr>
+          <a:lstStyle/>
+          <a:p>
+            <a:pPr>
+              <a:defRPr sz="2400" b="1">
+                <a:solidFill>
+                  <a:srgbClr val="EDF6FF"/>
+                </a:solidFill>
+                <a:latin typeface="Aptos"/>
+              </a:defRPr>
+            </a:pPr>
+            <a:r>
+              <a:t>Inclusive,</a:t>
+            </a:r>
+            <a:br/>
+            <a:r>
+              <a:t>evidence-aware</a:t>
+            </a:r>
+            <a:br/>
+            <a:r>
+              <a:t>brain–heart AI.</a:t>
+            </a:r>
+          </a:p>
+        </p:txBody>
+      </p:sp>
+      <p:sp>
+        <p:nvSpPr>
+          <p:cNvPr id="16" name="TextBox 15"/>
+          <p:cNvSpPr txBox="1"/>
+          <p:nvPr/>
+        </p:nvSpPr>
+        <p:spPr>
+          <a:xfrm>
+            <a:off x="7818120" y="4443984"/>
+            <a:ext cx="2743200" cy="438912"/>
+          </a:xfrm>
+          <a:prstGeom prst="rect">
+            <a:avLst/>
+          </a:prstGeom>
+          <a:noFill/>
+        </p:spPr>
+        <p:txBody>
+          <a:bodyPr wrap="square" anchor="t">
+            <a:spAutoFit/>
+          </a:bodyPr>
+          <a:lstStyle/>
+          <a:p>
+            <a:pPr>
+              <a:defRPr sz="1100" b="1">
+                <a:solidFill>
+                  <a:srgbClr val="5CE1A7"/>
+                </a:solidFill>
+                <a:latin typeface="Aptos"/>
+              </a:defRPr>
+            </a:pPr>
+            <a:r>
+              <a:t>Built in Bangladesh; designed for globally responsible digital-health research.</a:t>
+            </a:r>
+          </a:p>
+        </p:txBody>
+      </p:sp>
+      <p:sp>
+        <p:nvSpPr>
+          <p:cNvPr id="17" name="TextBox 16"/>
+          <p:cNvSpPr txBox="1"/>
+          <p:nvPr/>
+        </p:nvSpPr>
+        <p:spPr>
+          <a:xfrm>
+            <a:off x="566928" y="6519672"/>
+            <a:ext cx="7315200" cy="146304"/>
+          </a:xfrm>
+          <a:prstGeom prst="rect">
+            <a:avLst/>
+          </a:prstGeom>
+          <a:noFill/>
+        </p:spPr>
+        <p:txBody>
+          <a:bodyPr wrap="square" anchor="t">
+            <a:spAutoFit/>
+          </a:bodyPr>
+          <a:lstStyle/>
+          <a:p>
+            <a:pPr>
+              <a:defRPr sz="700" b="1">
+                <a:solidFill>
+                  <a:srgbClr val="A4BED6"/>
+                </a:solidFill>
+                <a:latin typeface="Courier New"/>
+              </a:defRPr>
+            </a:pPr>
+            <a:r>
+              <a:t>NEUROCARDIOTWIN  •  AI-POWERED BRAIN–HEART DIGITAL TWIN</a:t>
+            </a:r>
+          </a:p>
+        </p:txBody>
+      </p:sp>
+      <p:sp>
+        <p:nvSpPr>
+          <p:cNvPr id="18" name="TextBox 17"/>
+          <p:cNvSpPr txBox="1"/>
+          <p:nvPr/>
+        </p:nvSpPr>
+        <p:spPr>
+          <a:xfrm>
+            <a:off x="11109960" y="6483096"/>
+            <a:ext cx="502920" cy="182880"/>
+          </a:xfrm>
+          <a:prstGeom prst="rect">
+            <a:avLst/>
+          </a:prstGeom>
+          <a:noFill/>
+        </p:spPr>
+        <p:txBody>
+          <a:bodyPr wrap="square" anchor="t">
+            <a:spAutoFit/>
+          </a:bodyPr>
+          <a:lstStyle/>
+          <a:p>
+            <a:pPr algn="r">
+              <a:defRPr sz="900" b="1">
+                <a:solidFill>
+                  <a:srgbClr val="22D3EE"/>
+                </a:solidFill>
+                <a:latin typeface="Courier New"/>
+              </a:defRPr>
+            </a:pPr>
+            <a:r>
+              <a:t>10</a:t>
+            </a:r>
+          </a:p>
+        </p:txBody>
+      </p:sp>
+    </p:spTree>
+  </p:cSld>
+  <p:clrMapOvr>
+    <a:masterClrMapping/>
+  </p:clrMapOvr>
+</p:sld>
+</file>
+
+<file path=ppt/slides/slide11.xml><?xml version="1.0" encoding="utf-8"?>
+<p:sld xmlns:a="http://schemas.openxmlformats.org/drawingml/2006/main" xmlns:p="http://schemas.openxmlformats.org/presentationml/2006/main" xmlns:r="http://schemas.openxmlformats.org/officeDocument/2006/relationships">
+  <p:cSld>
+    <p:bg>
+      <p:bgPr>
+        <a:solidFill>
+          <a:srgbClr val="071122"/>
+        </a:solidFill>
+        <a:effectLst/>
+      </p:bgPr>
+    </p:bg>
+    <p:spTree>
+      <p:nvGrpSpPr>
+        <p:cNvPr id="1" name=""/>
+        <p:cNvGrpSpPr/>
+        <p:nvPr/>
+      </p:nvGrpSpPr>
+      <p:grpSpPr/>
+      <p:sp>
+        <p:nvSpPr>
           <p:cNvPr id="2" name="Oval 1"/>
           <p:cNvSpPr/>
           <p:nvPr/>
@@ -3952,7 +4615,7 @@
               </a:defRPr>
             </a:pPr>
             <a:r>
-              <a:t>10</a:t>
+              <a:t>11</a:t>
             </a:r>
           </a:p>
         </p:txBody>
@@ -9191,7 +9854,7 @@
               </a:defRPr>
             </a:pPr>
             <a:r>
-              <a:t>WHAT WE VALIDATE</a:t>
+              <a:t>SAFETY ESCALATION</a:t>
             </a:r>
           </a:p>
         </p:txBody>
@@ -9227,7 +9890,7 @@
               </a:defRPr>
             </a:pPr>
             <a:r>
-              <a:t>Real model execution—not invented metrics.</a:t>
+              <a:t>AI is not the last stop in an emergency.</a:t>
             </a:r>
           </a:p>
         </p:txBody>
@@ -9263,7 +9926,7 @@
               </a:defRPr>
             </a:pPr>
             <a:r>
-              <a:t>Model performance is reported from the connected backend, while the interface exposes input and runtime constraints.</a:t>
+              <a:t>NeuroCardioTwin keeps the emergency path separate from model inference and assistant chat.</a:t>
             </a:r>
           </a:p>
         </p:txBody>
@@ -9319,8 +9982,8 @@
         </p:nvSpPr>
         <p:spPr>
           <a:xfrm>
-            <a:off x="640080" y="2148840"/>
-            <a:ext cx="3474720" cy="2011680"/>
+            <a:off x="658368" y="2148840"/>
+            <a:ext cx="3401568" cy="2331720"/>
           </a:xfrm>
           <a:prstGeom prst="roundRect">
             <a:avLst/>
@@ -9364,18 +10027,18 @@
         </p:nvSpPr>
         <p:spPr>
           <a:xfrm>
-            <a:off x="822960" y="2331720"/>
+            <a:off x="841248" y="2331720"/>
             <a:ext cx="438912" cy="438912"/>
           </a:xfrm>
           <a:prstGeom prst="roundRect">
             <a:avLst/>
           </a:prstGeom>
           <a:solidFill>
-            <a:srgbClr val="22D3EE"/>
+            <a:srgbClr val="FBBF24"/>
           </a:solidFill>
           <a:ln>
             <a:solidFill>
-              <a:srgbClr val="22D3EE"/>
+              <a:srgbClr val="FBBF24"/>
             </a:solidFill>
           </a:ln>
         </p:spPr>
@@ -9409,7 +10072,7 @@
         </p:nvSpPr>
         <p:spPr>
           <a:xfrm>
-            <a:off x="822960" y="2395728"/>
+            <a:off x="841248" y="2395728"/>
             <a:ext cx="438912" cy="201168"/>
           </a:xfrm>
           <a:prstGeom prst="rect">
@@ -9432,7 +10095,7 @@
               </a:defRPr>
             </a:pPr>
             <a:r>
-              <a:t>✓</a:t>
+              <a:t>!</a:t>
             </a:r>
           </a:p>
         </p:txBody>
@@ -9445,8 +10108,8 @@
         </p:nvSpPr>
         <p:spPr>
           <a:xfrm>
-            <a:off x="1389888" y="2350008"/>
-            <a:ext cx="2560320" cy="256032"/>
+            <a:off x="1408176" y="2350008"/>
+            <a:ext cx="2487168" cy="256032"/>
           </a:xfrm>
           <a:prstGeom prst="rect">
             <a:avLst/>
@@ -9468,7 +10131,7 @@
               </a:defRPr>
             </a:pPr>
             <a:r>
-              <a:t>Input integrity</a:t>
+              <a:t>Recognise</a:t>
             </a:r>
           </a:p>
         </p:txBody>
@@ -9481,8 +10144,8 @@
         </p:nvSpPr>
         <p:spPr>
           <a:xfrm>
-            <a:off x="841248" y="2916936"/>
-            <a:ext cx="3072384" cy="1097280"/>
+            <a:off x="859536" y="2916936"/>
+            <a:ext cx="2999232" cy="1417320"/>
           </a:xfrm>
           <a:prstGeom prst="rect">
             <a:avLst/>
@@ -9504,7 +10167,7 @@
               </a:defRPr>
             </a:pPr>
             <a:r>
-              <a:t>Required sample windows, finite-value checks, sampling rate, and validated input state before inference.</a:t>
+              <a:t>Visible urgent-warning panel covers chest pain or pressure, severe breathing difficulty, fainting, confusion, seizure and severe bleeding.</a:t>
             </a:r>
           </a:p>
         </p:txBody>
@@ -9517,8 +10180,8 @@
         </p:nvSpPr>
         <p:spPr>
           <a:xfrm>
-            <a:off x="4370832" y="2148840"/>
-            <a:ext cx="3474720" cy="2011680"/>
+            <a:off x="4407408" y="2148840"/>
+            <a:ext cx="3401568" cy="2331720"/>
           </a:xfrm>
           <a:prstGeom prst="roundRect">
             <a:avLst/>
@@ -9562,18 +10225,18 @@
         </p:nvSpPr>
         <p:spPr>
           <a:xfrm>
-            <a:off x="4553712" y="2331720"/>
+            <a:off x="4590288" y="2331720"/>
             <a:ext cx="438912" cy="438912"/>
           </a:xfrm>
           <a:prstGeom prst="roundRect">
             <a:avLst/>
           </a:prstGeom>
           <a:solidFill>
-            <a:srgbClr val="14B8A6"/>
+            <a:srgbClr val="E11D48"/>
           </a:solidFill>
           <a:ln>
             <a:solidFill>
-              <a:srgbClr val="14B8A6"/>
+              <a:srgbClr val="E11D48"/>
             </a:solidFill>
           </a:ln>
         </p:spPr>
@@ -9607,7 +10270,7 @@
         </p:nvSpPr>
         <p:spPr>
           <a:xfrm>
-            <a:off x="4553712" y="2395728"/>
+            <a:off x="4590288" y="2395728"/>
             <a:ext cx="438912" cy="201168"/>
           </a:xfrm>
           <a:prstGeom prst="rect">
@@ -9630,7 +10293,7 @@
               </a:defRPr>
             </a:pPr>
             <a:r>
-              <a:t>↗</a:t>
+              <a:t>☎</a:t>
             </a:r>
           </a:p>
         </p:txBody>
@@ -9643,8 +10306,8 @@
         </p:nvSpPr>
         <p:spPr>
           <a:xfrm>
-            <a:off x="5120640" y="2350008"/>
-            <a:ext cx="2560320" cy="256032"/>
+            <a:off x="5157216" y="2350008"/>
+            <a:ext cx="2487168" cy="256032"/>
           </a:xfrm>
           <a:prstGeom prst="rect">
             <a:avLst/>
@@ -9666,7 +10329,7 @@
               </a:defRPr>
             </a:pPr>
             <a:r>
-              <a:t>Operational proof</a:t>
+              <a:t>Act</a:t>
             </a:r>
           </a:p>
         </p:txBody>
@@ -9679,8 +10342,8 @@
         </p:nvSpPr>
         <p:spPr>
           <a:xfrm>
-            <a:off x="4572000" y="2916936"/>
-            <a:ext cx="3072384" cy="1097280"/>
+            <a:off x="4608576" y="2916936"/>
+            <a:ext cx="2999232" cy="1417320"/>
           </a:xfrm>
           <a:prstGeom prst="rect">
             <a:avLst/>
@@ -9702,7 +10365,7 @@
               </a:defRPr>
             </a:pPr>
             <a:r>
-              <a:t>ONNX CPU model status, output confidence, classification/forecast details, and API-backed metrics surfaces.</a:t>
+              <a:t>One tap opens the phone dialler for Bangladesh National Emergency Service 999. The interface tells users not to wait for an AI reply.</a:t>
             </a:r>
           </a:p>
         </p:txBody>
@@ -9715,8 +10378,8 @@
         </p:nvSpPr>
         <p:spPr>
           <a:xfrm>
-            <a:off x="8101583" y="2148840"/>
-            <a:ext cx="3474720" cy="2011680"/>
+            <a:off x="8156448" y="2148840"/>
+            <a:ext cx="3401568" cy="2331720"/>
           </a:xfrm>
           <a:prstGeom prst="roundRect">
             <a:avLst/>
@@ -9760,7 +10423,7 @@
         </p:nvSpPr>
         <p:spPr>
           <a:xfrm>
-            <a:off x="8284463" y="2331720"/>
+            <a:off x="8339328" y="2331720"/>
             <a:ext cx="438912" cy="438912"/>
           </a:xfrm>
           <a:prstGeom prst="roundRect">
@@ -9805,7 +10468,7 @@
         </p:nvSpPr>
         <p:spPr>
           <a:xfrm>
-            <a:off x="8284463" y="2395728"/>
+            <a:off x="8339328" y="2395728"/>
             <a:ext cx="438912" cy="201168"/>
           </a:xfrm>
           <a:prstGeom prst="rect">
@@ -9828,7 +10491,7 @@
               </a:defRPr>
             </a:pPr>
             <a:r>
-              <a:t>#</a:t>
+              <a:t>✓</a:t>
             </a:r>
           </a:p>
         </p:txBody>
@@ -9841,8 +10504,8 @@
         </p:nvSpPr>
         <p:spPr>
           <a:xfrm>
-            <a:off x="8851391" y="2350008"/>
-            <a:ext cx="2560320" cy="256032"/>
+            <a:off x="8906256" y="2350008"/>
+            <a:ext cx="2487168" cy="256032"/>
           </a:xfrm>
           <a:prstGeom prst="rect">
             <a:avLst/>
@@ -9864,7 +10527,7 @@
               </a:defRPr>
             </a:pPr>
             <a:r>
-              <a:t>Evidence traceability</a:t>
+              <a:t>Support</a:t>
             </a:r>
           </a:p>
         </p:txBody>
@@ -9877,8 +10540,8 @@
         </p:nvSpPr>
         <p:spPr>
           <a:xfrm>
-            <a:off x="8302751" y="2916936"/>
-            <a:ext cx="3072384" cy="1097280"/>
+            <a:off x="8357616" y="2916936"/>
+            <a:ext cx="2999232" cy="1417320"/>
           </a:xfrm>
           <a:prstGeom prst="rect">
             <a:avLst/>
@@ -9900,44 +10563,53 @@
               </a:defRPr>
             </a:pPr>
             <a:r>
-              <a:t>Decision outputs cite approved knowledge titles, making the RAG layer inspectable by judges.</a:t>
-            </a:r>
-          </a:p>
-        </p:txBody>
-      </p:sp>
-      <p:sp>
-        <p:nvSpPr>
-          <p:cNvPr id="21" name="TextBox 20"/>
-          <p:cNvSpPr txBox="1"/>
-          <p:nvPr/>
-        </p:nvSpPr>
-        <p:spPr>
-          <a:xfrm>
-            <a:off x="658368" y="4782312"/>
-            <a:ext cx="1645920" cy="201168"/>
-          </a:xfrm>
-          <a:prstGeom prst="rect">
-            <a:avLst/>
-          </a:prstGeom>
-          <a:noFill/>
-        </p:spPr>
-        <p:txBody>
-          <a:bodyPr wrap="square" anchor="t">
-            <a:spAutoFit/>
-          </a:bodyPr>
-          <a:lstStyle/>
-          <a:p>
-            <a:pPr>
-              <a:defRPr sz="1000" b="1">
-                <a:solidFill>
-                  <a:srgbClr val="FBBF24"/>
-                </a:solidFill>
-                <a:latin typeface="Courier New"/>
-              </a:defRPr>
-            </a:pPr>
-            <a:r>
-              <a:t>Honest claim</a:t>
-            </a:r>
+              <a:t>Bilingual Bengali/English instructions: alert someone nearby, do not stay alone, keep the phone available, and avoid driving when severely unwell.</a:t>
+            </a:r>
+          </a:p>
+        </p:txBody>
+      </p:sp>
+      <p:sp>
+        <p:nvSpPr>
+          <p:cNvPr id="21" name="Rounded Rectangle 20"/>
+          <p:cNvSpPr/>
+          <p:nvPr/>
+        </p:nvSpPr>
+        <p:spPr>
+          <a:xfrm>
+            <a:off x="1115568" y="4983480"/>
+            <a:ext cx="9235440" cy="548640"/>
+          </a:xfrm>
+          <a:prstGeom prst="roundRect">
+            <a:avLst/>
+          </a:prstGeom>
+          <a:solidFill>
+            <a:srgbClr val="3F1825"/>
+          </a:solidFill>
+          <a:ln>
+            <a:solidFill>
+              <a:srgbClr val="B44257"/>
+            </a:solidFill>
+          </a:ln>
+        </p:spPr>
+        <p:style>
+          <a:lnRef idx="1">
+            <a:schemeClr val="accent1"/>
+          </a:lnRef>
+          <a:fillRef idx="3">
+            <a:schemeClr val="accent1"/>
+          </a:fillRef>
+          <a:effectRef idx="2">
+            <a:schemeClr val="accent1"/>
+          </a:effectRef>
+          <a:fontRef idx="minor">
+            <a:schemeClr val="lt1"/>
+          </a:fontRef>
+        </p:style>
+        <p:txBody>
+          <a:bodyPr rtlCol="0" anchor="ctr"/>
+          <a:lstStyle/>
+          <a:p>
+            <a:pPr algn="ctr"/>
           </a:p>
         </p:txBody>
       </p:sp>
@@ -9949,30 +10621,30 @@
         </p:nvSpPr>
         <p:spPr>
           <a:xfrm>
-            <a:off x="658368" y="5074920"/>
-            <a:ext cx="10149840" cy="438912"/>
-          </a:xfrm>
-          <a:prstGeom prst="rect">
-            <a:avLst/>
-          </a:prstGeom>
-          <a:noFill/>
-        </p:spPr>
-        <p:txBody>
-          <a:bodyPr wrap="square" anchor="t">
-            <a:spAutoFit/>
-          </a:bodyPr>
-          <a:lstStyle/>
-          <a:p>
-            <a:pPr>
-              <a:defRPr sz="1800" b="1">
-                <a:solidFill>
-                  <a:srgbClr val="EDF6FF"/>
+            <a:off x="1371600" y="5175504"/>
+            <a:ext cx="8732520" cy="201168"/>
+          </a:xfrm>
+          <a:prstGeom prst="rect">
+            <a:avLst/>
+          </a:prstGeom>
+          <a:noFill/>
+        </p:spPr>
+        <p:txBody>
+          <a:bodyPr wrap="square" anchor="t">
+            <a:spAutoFit/>
+          </a:bodyPr>
+          <a:lstStyle/>
+          <a:p>
+            <a:pPr algn="ctr">
+              <a:defRPr sz="1200" b="1">
+                <a:solidFill>
+                  <a:srgbClr val="FFDAE0"/>
                 </a:solidFill>
                 <a:latin typeface="Aptos"/>
               </a:defRPr>
             </a:pPr>
             <a:r>
-              <a:t>This is a research prototype, not a clinical device. Its strength is a transparent, reproducible workflow—not overstated medical claims.</a:t>
+              <a:t>Safety boundary: the app never diagnoses an emergency; it makes the fastest real-world help path obvious.</a:t>
             </a:r>
           </a:p>
         </p:txBody>
@@ -10106,7 +10778,7 @@
               </a:defRPr>
             </a:pPr>
             <a:r>
-              <a:t>IMPACT &amp; NEXT STEPS</a:t>
+              <a:t>WHAT WE VALIDATE</a:t>
             </a:r>
           </a:p>
         </p:txBody>
@@ -10142,14 +10814,50 @@
               </a:defRPr>
             </a:pPr>
             <a:r>
-              <a:t>A platform designed to grow with the research community.</a:t>
-            </a:r>
-          </a:p>
-        </p:txBody>
-      </p:sp>
-      <p:sp>
-        <p:nvSpPr>
-          <p:cNvPr id="4" name="Rectangle 3"/>
+              <a:t>Real model execution—not invented metrics.</a:t>
+            </a:r>
+          </a:p>
+        </p:txBody>
+      </p:sp>
+      <p:sp>
+        <p:nvSpPr>
+          <p:cNvPr id="4" name="TextBox 3"/>
+          <p:cNvSpPr txBox="1"/>
+          <p:nvPr/>
+        </p:nvSpPr>
+        <p:spPr>
+          <a:xfrm>
+            <a:off x="566928" y="1225296"/>
+            <a:ext cx="10607040" cy="438912"/>
+          </a:xfrm>
+          <a:prstGeom prst="rect">
+            <a:avLst/>
+          </a:prstGeom>
+          <a:noFill/>
+        </p:spPr>
+        <p:txBody>
+          <a:bodyPr wrap="square" anchor="t">
+            <a:spAutoFit/>
+          </a:bodyPr>
+          <a:lstStyle/>
+          <a:p>
+            <a:pPr>
+              <a:defRPr sz="1200" b="0">
+                <a:solidFill>
+                  <a:srgbClr val="A4BED6"/>
+                </a:solidFill>
+                <a:latin typeface="Aptos"/>
+              </a:defRPr>
+            </a:pPr>
+            <a:r>
+              <a:t>Model performance is reported from the connected backend, while the interface exposes input and runtime constraints.</a:t>
+            </a:r>
+          </a:p>
+        </p:txBody>
+      </p:sp>
+      <p:sp>
+        <p:nvSpPr>
+          <p:cNvPr id="5" name="Rectangle 4"/>
           <p:cNvSpPr/>
           <p:nvPr/>
         </p:nvSpPr>
@@ -10192,302 +10900,14 @@
       </p:sp>
       <p:sp>
         <p:nvSpPr>
-          <p:cNvPr id="5" name="TextBox 4"/>
-          <p:cNvSpPr txBox="1"/>
-          <p:nvPr/>
-        </p:nvSpPr>
-        <p:spPr>
-          <a:xfrm>
-            <a:off x="777240" y="2057400"/>
-            <a:ext cx="201168" cy="219456"/>
-          </a:xfrm>
-          <a:prstGeom prst="rect">
-            <a:avLst/>
-          </a:prstGeom>
-          <a:noFill/>
-        </p:spPr>
-        <p:txBody>
-          <a:bodyPr wrap="square" anchor="t">
-            <a:spAutoFit/>
-          </a:bodyPr>
-          <a:lstStyle/>
-          <a:p>
-            <a:pPr>
-              <a:defRPr sz="1000" b="0">
-                <a:solidFill>
-                  <a:srgbClr val="22D3EE"/>
-                </a:solidFill>
-                <a:latin typeface="Aptos"/>
-              </a:defRPr>
-            </a:pPr>
-            <a:r>
-              <a:t>●</a:t>
-            </a:r>
-          </a:p>
-        </p:txBody>
-      </p:sp>
-      <p:sp>
-        <p:nvSpPr>
-          <p:cNvPr id="6" name="TextBox 5"/>
-          <p:cNvSpPr txBox="1"/>
-          <p:nvPr/>
-        </p:nvSpPr>
-        <p:spPr>
-          <a:xfrm>
-            <a:off x="1033272" y="2043684"/>
-            <a:ext cx="6053328" cy="347472"/>
-          </a:xfrm>
-          <a:prstGeom prst="rect">
-            <a:avLst/>
-          </a:prstGeom>
-          <a:noFill/>
-        </p:spPr>
-        <p:txBody>
-          <a:bodyPr wrap="square" anchor="t">
-            <a:spAutoFit/>
-          </a:bodyPr>
-          <a:lstStyle/>
-          <a:p>
-            <a:pPr>
-              <a:defRPr sz="1400" b="0">
-                <a:solidFill>
-                  <a:srgbClr val="EDF6FF"/>
-                </a:solidFill>
-                <a:latin typeface="Aptos"/>
-              </a:defRPr>
-            </a:pPr>
-            <a:r>
-              <a:t>Pilot with supervised research teams using consented, de-identified signal datasets.</a:t>
-            </a:r>
-          </a:p>
-        </p:txBody>
-      </p:sp>
-      <p:sp>
-        <p:nvSpPr>
-          <p:cNvPr id="7" name="TextBox 6"/>
-          <p:cNvSpPr txBox="1"/>
-          <p:nvPr/>
-        </p:nvSpPr>
-        <p:spPr>
-          <a:xfrm>
-            <a:off x="777240" y="2679192"/>
-            <a:ext cx="201168" cy="219456"/>
-          </a:xfrm>
-          <a:prstGeom prst="rect">
-            <a:avLst/>
-          </a:prstGeom>
-          <a:noFill/>
-        </p:spPr>
-        <p:txBody>
-          <a:bodyPr wrap="square" anchor="t">
-            <a:spAutoFit/>
-          </a:bodyPr>
-          <a:lstStyle/>
-          <a:p>
-            <a:pPr>
-              <a:defRPr sz="1000" b="0">
-                <a:solidFill>
-                  <a:srgbClr val="22D3EE"/>
-                </a:solidFill>
-                <a:latin typeface="Aptos"/>
-              </a:defRPr>
-            </a:pPr>
-            <a:r>
-              <a:t>●</a:t>
-            </a:r>
-          </a:p>
-        </p:txBody>
-      </p:sp>
-      <p:sp>
-        <p:nvSpPr>
-          <p:cNvPr id="8" name="TextBox 7"/>
-          <p:cNvSpPr txBox="1"/>
-          <p:nvPr/>
-        </p:nvSpPr>
-        <p:spPr>
-          <a:xfrm>
-            <a:off x="1033272" y="2665476"/>
-            <a:ext cx="6053328" cy="347472"/>
-          </a:xfrm>
-          <a:prstGeom prst="rect">
-            <a:avLst/>
-          </a:prstGeom>
-          <a:noFill/>
-        </p:spPr>
-        <p:txBody>
-          <a:bodyPr wrap="square" anchor="t">
-            <a:spAutoFit/>
-          </a:bodyPr>
-          <a:lstStyle/>
-          <a:p>
-            <a:pPr>
-              <a:defRPr sz="1400" b="0">
-                <a:solidFill>
-                  <a:srgbClr val="EDF6FF"/>
-                </a:solidFill>
-                <a:latin typeface="Aptos"/>
-              </a:defRPr>
-            </a:pPr>
-            <a:r>
-              <a:t>Expand the approved knowledge base through clinician/researcher review workflows.</a:t>
-            </a:r>
-          </a:p>
-        </p:txBody>
-      </p:sp>
-      <p:sp>
-        <p:nvSpPr>
-          <p:cNvPr id="9" name="TextBox 8"/>
-          <p:cNvSpPr txBox="1"/>
-          <p:nvPr/>
-        </p:nvSpPr>
-        <p:spPr>
-          <a:xfrm>
-            <a:off x="777240" y="3300984"/>
-            <a:ext cx="201168" cy="219456"/>
-          </a:xfrm>
-          <a:prstGeom prst="rect">
-            <a:avLst/>
-          </a:prstGeom>
-          <a:noFill/>
-        </p:spPr>
-        <p:txBody>
-          <a:bodyPr wrap="square" anchor="t">
-            <a:spAutoFit/>
-          </a:bodyPr>
-          <a:lstStyle/>
-          <a:p>
-            <a:pPr>
-              <a:defRPr sz="1000" b="0">
-                <a:solidFill>
-                  <a:srgbClr val="22D3EE"/>
-                </a:solidFill>
-                <a:latin typeface="Aptos"/>
-              </a:defRPr>
-            </a:pPr>
-            <a:r>
-              <a:t>●</a:t>
-            </a:r>
-          </a:p>
-        </p:txBody>
-      </p:sp>
-      <p:sp>
-        <p:nvSpPr>
-          <p:cNvPr id="10" name="TextBox 9"/>
-          <p:cNvSpPr txBox="1"/>
-          <p:nvPr/>
-        </p:nvSpPr>
-        <p:spPr>
-          <a:xfrm>
-            <a:off x="1033272" y="3287268"/>
-            <a:ext cx="6053328" cy="347472"/>
-          </a:xfrm>
-          <a:prstGeom prst="rect">
-            <a:avLst/>
-          </a:prstGeom>
-          <a:noFill/>
-        </p:spPr>
-        <p:txBody>
-          <a:bodyPr wrap="square" anchor="t">
-            <a:spAutoFit/>
-          </a:bodyPr>
-          <a:lstStyle/>
-          <a:p>
-            <a:pPr>
-              <a:defRPr sz="1400" b="0">
-                <a:solidFill>
-                  <a:srgbClr val="EDF6FF"/>
-                </a:solidFill>
-                <a:latin typeface="Aptos"/>
-              </a:defRPr>
-            </a:pPr>
-            <a:r>
-              <a:t>Add calibrated model evaluation, cohort-level fairness analysis, and reproducible audit exports.</a:t>
-            </a:r>
-          </a:p>
-        </p:txBody>
-      </p:sp>
-      <p:sp>
-        <p:nvSpPr>
-          <p:cNvPr id="11" name="TextBox 10"/>
-          <p:cNvSpPr txBox="1"/>
-          <p:nvPr/>
-        </p:nvSpPr>
-        <p:spPr>
-          <a:xfrm>
-            <a:off x="777240" y="3922776"/>
-            <a:ext cx="201168" cy="219456"/>
-          </a:xfrm>
-          <a:prstGeom prst="rect">
-            <a:avLst/>
-          </a:prstGeom>
-          <a:noFill/>
-        </p:spPr>
-        <p:txBody>
-          <a:bodyPr wrap="square" anchor="t">
-            <a:spAutoFit/>
-          </a:bodyPr>
-          <a:lstStyle/>
-          <a:p>
-            <a:pPr>
-              <a:defRPr sz="1000" b="0">
-                <a:solidFill>
-                  <a:srgbClr val="22D3EE"/>
-                </a:solidFill>
-                <a:latin typeface="Aptos"/>
-              </a:defRPr>
-            </a:pPr>
-            <a:r>
-              <a:t>●</a:t>
-            </a:r>
-          </a:p>
-        </p:txBody>
-      </p:sp>
-      <p:sp>
-        <p:nvSpPr>
-          <p:cNvPr id="12" name="TextBox 11"/>
-          <p:cNvSpPr txBox="1"/>
-          <p:nvPr/>
-        </p:nvSpPr>
-        <p:spPr>
-          <a:xfrm>
-            <a:off x="1033272" y="3909060"/>
-            <a:ext cx="6053328" cy="347472"/>
-          </a:xfrm>
-          <a:prstGeom prst="rect">
-            <a:avLst/>
-          </a:prstGeom>
-          <a:noFill/>
-        </p:spPr>
-        <p:txBody>
-          <a:bodyPr wrap="square" anchor="t">
-            <a:spAutoFit/>
-          </a:bodyPr>
-          <a:lstStyle/>
-          <a:p>
-            <a:pPr>
-              <a:defRPr sz="1400" b="0">
-                <a:solidFill>
-                  <a:srgbClr val="EDF6FF"/>
-                </a:solidFill>
-                <a:latin typeface="Aptos"/>
-              </a:defRPr>
-            </a:pPr>
-            <a:r>
-              <a:t>Connect validated real-time devices only after robust signal-quality and governance testing.</a:t>
-            </a:r>
-          </a:p>
-        </p:txBody>
-      </p:sp>
-      <p:sp>
-        <p:nvSpPr>
-          <p:cNvPr id="13" name="Rounded Rectangle 12"/>
+          <p:cNvPr id="6" name="Rounded Rectangle 5"/>
           <p:cNvSpPr/>
           <p:nvPr/>
         </p:nvSpPr>
         <p:spPr>
           <a:xfrm>
-            <a:off x="7543800" y="2057400"/>
-            <a:ext cx="3657600" cy="3108960"/>
+            <a:off x="640080" y="2148840"/>
+            <a:ext cx="3474720" cy="2011680"/>
           </a:xfrm>
           <a:prstGeom prst="roundRect">
             <a:avLst/>
@@ -10497,7 +10917,7 @@
           </a:solidFill>
           <a:ln>
             <a:solidFill>
-              <a:srgbClr val="315779"/>
+              <a:srgbClr val="2F5476"/>
             </a:solidFill>
           </a:ln>
         </p:spPr>
@@ -10525,14 +10945,563 @@
       </p:sp>
       <p:sp>
         <p:nvSpPr>
+          <p:cNvPr id="7" name="Rounded Rectangle 6"/>
+          <p:cNvSpPr/>
+          <p:nvPr/>
+        </p:nvSpPr>
+        <p:spPr>
+          <a:xfrm>
+            <a:off x="822960" y="2331720"/>
+            <a:ext cx="438912" cy="438912"/>
+          </a:xfrm>
+          <a:prstGeom prst="roundRect">
+            <a:avLst/>
+          </a:prstGeom>
+          <a:solidFill>
+            <a:srgbClr val="22D3EE"/>
+          </a:solidFill>
+          <a:ln>
+            <a:solidFill>
+              <a:srgbClr val="22D3EE"/>
+            </a:solidFill>
+          </a:ln>
+        </p:spPr>
+        <p:style>
+          <a:lnRef idx="1">
+            <a:schemeClr val="accent1"/>
+          </a:lnRef>
+          <a:fillRef idx="3">
+            <a:schemeClr val="accent1"/>
+          </a:fillRef>
+          <a:effectRef idx="2">
+            <a:schemeClr val="accent1"/>
+          </a:effectRef>
+          <a:fontRef idx="minor">
+            <a:schemeClr val="lt1"/>
+          </a:fontRef>
+        </p:style>
+        <p:txBody>
+          <a:bodyPr rtlCol="0" anchor="ctr"/>
+          <a:lstStyle/>
+          <a:p>
+            <a:pPr algn="ctr"/>
+          </a:p>
+        </p:txBody>
+      </p:sp>
+      <p:sp>
+        <p:nvSpPr>
+          <p:cNvPr id="8" name="TextBox 7"/>
+          <p:cNvSpPr txBox="1"/>
+          <p:nvPr/>
+        </p:nvSpPr>
+        <p:spPr>
+          <a:xfrm>
+            <a:off x="822960" y="2395728"/>
+            <a:ext cx="438912" cy="201168"/>
+          </a:xfrm>
+          <a:prstGeom prst="rect">
+            <a:avLst/>
+          </a:prstGeom>
+          <a:noFill/>
+        </p:spPr>
+        <p:txBody>
+          <a:bodyPr wrap="square" anchor="t">
+            <a:spAutoFit/>
+          </a:bodyPr>
+          <a:lstStyle/>
+          <a:p>
+            <a:pPr algn="ctr">
+              <a:defRPr sz="1500" b="1">
+                <a:solidFill>
+                  <a:srgbClr val="071122"/>
+                </a:solidFill>
+                <a:latin typeface="Aptos"/>
+              </a:defRPr>
+            </a:pPr>
+            <a:r>
+              <a:t>✓</a:t>
+            </a:r>
+          </a:p>
+        </p:txBody>
+      </p:sp>
+      <p:sp>
+        <p:nvSpPr>
+          <p:cNvPr id="9" name="TextBox 8"/>
+          <p:cNvSpPr txBox="1"/>
+          <p:nvPr/>
+        </p:nvSpPr>
+        <p:spPr>
+          <a:xfrm>
+            <a:off x="1389888" y="2350008"/>
+            <a:ext cx="2560320" cy="256032"/>
+          </a:xfrm>
+          <a:prstGeom prst="rect">
+            <a:avLst/>
+          </a:prstGeom>
+          <a:noFill/>
+        </p:spPr>
+        <p:txBody>
+          <a:bodyPr wrap="square" anchor="t">
+            <a:spAutoFit/>
+          </a:bodyPr>
+          <a:lstStyle/>
+          <a:p>
+            <a:pPr>
+              <a:defRPr sz="1400" b="1">
+                <a:solidFill>
+                  <a:srgbClr val="EDF6FF"/>
+                </a:solidFill>
+                <a:latin typeface="Aptos"/>
+              </a:defRPr>
+            </a:pPr>
+            <a:r>
+              <a:t>Input integrity</a:t>
+            </a:r>
+          </a:p>
+        </p:txBody>
+      </p:sp>
+      <p:sp>
+        <p:nvSpPr>
+          <p:cNvPr id="10" name="TextBox 9"/>
+          <p:cNvSpPr txBox="1"/>
+          <p:nvPr/>
+        </p:nvSpPr>
+        <p:spPr>
+          <a:xfrm>
+            <a:off x="841248" y="2916936"/>
+            <a:ext cx="3072384" cy="1097280"/>
+          </a:xfrm>
+          <a:prstGeom prst="rect">
+            <a:avLst/>
+          </a:prstGeom>
+          <a:noFill/>
+        </p:spPr>
+        <p:txBody>
+          <a:bodyPr wrap="square" anchor="t">
+            <a:spAutoFit/>
+          </a:bodyPr>
+          <a:lstStyle/>
+          <a:p>
+            <a:pPr>
+              <a:defRPr sz="1150" b="0">
+                <a:solidFill>
+                  <a:srgbClr val="A4BED6"/>
+                </a:solidFill>
+                <a:latin typeface="Aptos"/>
+              </a:defRPr>
+            </a:pPr>
+            <a:r>
+              <a:t>Required sample windows, finite-value checks, sampling rate, and validated input state before inference.</a:t>
+            </a:r>
+          </a:p>
+        </p:txBody>
+      </p:sp>
+      <p:sp>
+        <p:nvSpPr>
+          <p:cNvPr id="11" name="Rounded Rectangle 10"/>
+          <p:cNvSpPr/>
+          <p:nvPr/>
+        </p:nvSpPr>
+        <p:spPr>
+          <a:xfrm>
+            <a:off x="4370832" y="2148840"/>
+            <a:ext cx="3474720" cy="2011680"/>
+          </a:xfrm>
+          <a:prstGeom prst="roundRect">
+            <a:avLst/>
+          </a:prstGeom>
+          <a:solidFill>
+            <a:srgbClr val="122740"/>
+          </a:solidFill>
+          <a:ln>
+            <a:solidFill>
+              <a:srgbClr val="2F5476"/>
+            </a:solidFill>
+          </a:ln>
+        </p:spPr>
+        <p:style>
+          <a:lnRef idx="1">
+            <a:schemeClr val="accent1"/>
+          </a:lnRef>
+          <a:fillRef idx="3">
+            <a:schemeClr val="accent1"/>
+          </a:fillRef>
+          <a:effectRef idx="2">
+            <a:schemeClr val="accent1"/>
+          </a:effectRef>
+          <a:fontRef idx="minor">
+            <a:schemeClr val="lt1"/>
+          </a:fontRef>
+        </p:style>
+        <p:txBody>
+          <a:bodyPr rtlCol="0" anchor="ctr"/>
+          <a:lstStyle/>
+          <a:p>
+            <a:pPr algn="ctr"/>
+          </a:p>
+        </p:txBody>
+      </p:sp>
+      <p:sp>
+        <p:nvSpPr>
+          <p:cNvPr id="12" name="Rounded Rectangle 11"/>
+          <p:cNvSpPr/>
+          <p:nvPr/>
+        </p:nvSpPr>
+        <p:spPr>
+          <a:xfrm>
+            <a:off x="4553712" y="2331720"/>
+            <a:ext cx="438912" cy="438912"/>
+          </a:xfrm>
+          <a:prstGeom prst="roundRect">
+            <a:avLst/>
+          </a:prstGeom>
+          <a:solidFill>
+            <a:srgbClr val="14B8A6"/>
+          </a:solidFill>
+          <a:ln>
+            <a:solidFill>
+              <a:srgbClr val="14B8A6"/>
+            </a:solidFill>
+          </a:ln>
+        </p:spPr>
+        <p:style>
+          <a:lnRef idx="1">
+            <a:schemeClr val="accent1"/>
+          </a:lnRef>
+          <a:fillRef idx="3">
+            <a:schemeClr val="accent1"/>
+          </a:fillRef>
+          <a:effectRef idx="2">
+            <a:schemeClr val="accent1"/>
+          </a:effectRef>
+          <a:fontRef idx="minor">
+            <a:schemeClr val="lt1"/>
+          </a:fontRef>
+        </p:style>
+        <p:txBody>
+          <a:bodyPr rtlCol="0" anchor="ctr"/>
+          <a:lstStyle/>
+          <a:p>
+            <a:pPr algn="ctr"/>
+          </a:p>
+        </p:txBody>
+      </p:sp>
+      <p:sp>
+        <p:nvSpPr>
+          <p:cNvPr id="13" name="TextBox 12"/>
+          <p:cNvSpPr txBox="1"/>
+          <p:nvPr/>
+        </p:nvSpPr>
+        <p:spPr>
+          <a:xfrm>
+            <a:off x="4553712" y="2395728"/>
+            <a:ext cx="438912" cy="201168"/>
+          </a:xfrm>
+          <a:prstGeom prst="rect">
+            <a:avLst/>
+          </a:prstGeom>
+          <a:noFill/>
+        </p:spPr>
+        <p:txBody>
+          <a:bodyPr wrap="square" anchor="t">
+            <a:spAutoFit/>
+          </a:bodyPr>
+          <a:lstStyle/>
+          <a:p>
+            <a:pPr algn="ctr">
+              <a:defRPr sz="1500" b="1">
+                <a:solidFill>
+                  <a:srgbClr val="071122"/>
+                </a:solidFill>
+                <a:latin typeface="Aptos"/>
+              </a:defRPr>
+            </a:pPr>
+            <a:r>
+              <a:t>↗</a:t>
+            </a:r>
+          </a:p>
+        </p:txBody>
+      </p:sp>
+      <p:sp>
+        <p:nvSpPr>
           <p:cNvPr id="14" name="TextBox 13"/>
           <p:cNvSpPr txBox="1"/>
           <p:nvPr/>
         </p:nvSpPr>
         <p:spPr>
           <a:xfrm>
-            <a:off x="7818120" y="2350008"/>
-            <a:ext cx="1828800" cy="182880"/>
+            <a:off x="5120640" y="2350008"/>
+            <a:ext cx="2560320" cy="256032"/>
+          </a:xfrm>
+          <a:prstGeom prst="rect">
+            <a:avLst/>
+          </a:prstGeom>
+          <a:noFill/>
+        </p:spPr>
+        <p:txBody>
+          <a:bodyPr wrap="square" anchor="t">
+            <a:spAutoFit/>
+          </a:bodyPr>
+          <a:lstStyle/>
+          <a:p>
+            <a:pPr>
+              <a:defRPr sz="1400" b="1">
+                <a:solidFill>
+                  <a:srgbClr val="EDF6FF"/>
+                </a:solidFill>
+                <a:latin typeface="Aptos"/>
+              </a:defRPr>
+            </a:pPr>
+            <a:r>
+              <a:t>Operational proof</a:t>
+            </a:r>
+          </a:p>
+        </p:txBody>
+      </p:sp>
+      <p:sp>
+        <p:nvSpPr>
+          <p:cNvPr id="15" name="TextBox 14"/>
+          <p:cNvSpPr txBox="1"/>
+          <p:nvPr/>
+        </p:nvSpPr>
+        <p:spPr>
+          <a:xfrm>
+            <a:off x="4572000" y="2916936"/>
+            <a:ext cx="3072384" cy="1097280"/>
+          </a:xfrm>
+          <a:prstGeom prst="rect">
+            <a:avLst/>
+          </a:prstGeom>
+          <a:noFill/>
+        </p:spPr>
+        <p:txBody>
+          <a:bodyPr wrap="square" anchor="t">
+            <a:spAutoFit/>
+          </a:bodyPr>
+          <a:lstStyle/>
+          <a:p>
+            <a:pPr>
+              <a:defRPr sz="1150" b="0">
+                <a:solidFill>
+                  <a:srgbClr val="A4BED6"/>
+                </a:solidFill>
+                <a:latin typeface="Aptos"/>
+              </a:defRPr>
+            </a:pPr>
+            <a:r>
+              <a:t>ONNX CPU model status, output confidence, classification/forecast details, and API-backed metrics surfaces.</a:t>
+            </a:r>
+          </a:p>
+        </p:txBody>
+      </p:sp>
+      <p:sp>
+        <p:nvSpPr>
+          <p:cNvPr id="16" name="Rounded Rectangle 15"/>
+          <p:cNvSpPr/>
+          <p:nvPr/>
+        </p:nvSpPr>
+        <p:spPr>
+          <a:xfrm>
+            <a:off x="8101583" y="2148840"/>
+            <a:ext cx="3474720" cy="2011680"/>
+          </a:xfrm>
+          <a:prstGeom prst="roundRect">
+            <a:avLst/>
+          </a:prstGeom>
+          <a:solidFill>
+            <a:srgbClr val="122740"/>
+          </a:solidFill>
+          <a:ln>
+            <a:solidFill>
+              <a:srgbClr val="2F5476"/>
+            </a:solidFill>
+          </a:ln>
+        </p:spPr>
+        <p:style>
+          <a:lnRef idx="1">
+            <a:schemeClr val="accent1"/>
+          </a:lnRef>
+          <a:fillRef idx="3">
+            <a:schemeClr val="accent1"/>
+          </a:fillRef>
+          <a:effectRef idx="2">
+            <a:schemeClr val="accent1"/>
+          </a:effectRef>
+          <a:fontRef idx="minor">
+            <a:schemeClr val="lt1"/>
+          </a:fontRef>
+        </p:style>
+        <p:txBody>
+          <a:bodyPr rtlCol="0" anchor="ctr"/>
+          <a:lstStyle/>
+          <a:p>
+            <a:pPr algn="ctr"/>
+          </a:p>
+        </p:txBody>
+      </p:sp>
+      <p:sp>
+        <p:nvSpPr>
+          <p:cNvPr id="17" name="Rounded Rectangle 16"/>
+          <p:cNvSpPr/>
+          <p:nvPr/>
+        </p:nvSpPr>
+        <p:spPr>
+          <a:xfrm>
+            <a:off x="8284463" y="2331720"/>
+            <a:ext cx="438912" cy="438912"/>
+          </a:xfrm>
+          <a:prstGeom prst="roundRect">
+            <a:avLst/>
+          </a:prstGeom>
+          <a:solidFill>
+            <a:srgbClr val="A78BFA"/>
+          </a:solidFill>
+          <a:ln>
+            <a:solidFill>
+              <a:srgbClr val="A78BFA"/>
+            </a:solidFill>
+          </a:ln>
+        </p:spPr>
+        <p:style>
+          <a:lnRef idx="1">
+            <a:schemeClr val="accent1"/>
+          </a:lnRef>
+          <a:fillRef idx="3">
+            <a:schemeClr val="accent1"/>
+          </a:fillRef>
+          <a:effectRef idx="2">
+            <a:schemeClr val="accent1"/>
+          </a:effectRef>
+          <a:fontRef idx="minor">
+            <a:schemeClr val="lt1"/>
+          </a:fontRef>
+        </p:style>
+        <p:txBody>
+          <a:bodyPr rtlCol="0" anchor="ctr"/>
+          <a:lstStyle/>
+          <a:p>
+            <a:pPr algn="ctr"/>
+          </a:p>
+        </p:txBody>
+      </p:sp>
+      <p:sp>
+        <p:nvSpPr>
+          <p:cNvPr id="18" name="TextBox 17"/>
+          <p:cNvSpPr txBox="1"/>
+          <p:nvPr/>
+        </p:nvSpPr>
+        <p:spPr>
+          <a:xfrm>
+            <a:off x="8284463" y="2395728"/>
+            <a:ext cx="438912" cy="201168"/>
+          </a:xfrm>
+          <a:prstGeom prst="rect">
+            <a:avLst/>
+          </a:prstGeom>
+          <a:noFill/>
+        </p:spPr>
+        <p:txBody>
+          <a:bodyPr wrap="square" anchor="t">
+            <a:spAutoFit/>
+          </a:bodyPr>
+          <a:lstStyle/>
+          <a:p>
+            <a:pPr algn="ctr">
+              <a:defRPr sz="1500" b="1">
+                <a:solidFill>
+                  <a:srgbClr val="071122"/>
+                </a:solidFill>
+                <a:latin typeface="Aptos"/>
+              </a:defRPr>
+            </a:pPr>
+            <a:r>
+              <a:t>#</a:t>
+            </a:r>
+          </a:p>
+        </p:txBody>
+      </p:sp>
+      <p:sp>
+        <p:nvSpPr>
+          <p:cNvPr id="19" name="TextBox 18"/>
+          <p:cNvSpPr txBox="1"/>
+          <p:nvPr/>
+        </p:nvSpPr>
+        <p:spPr>
+          <a:xfrm>
+            <a:off x="8851391" y="2350008"/>
+            <a:ext cx="2560320" cy="256032"/>
+          </a:xfrm>
+          <a:prstGeom prst="rect">
+            <a:avLst/>
+          </a:prstGeom>
+          <a:noFill/>
+        </p:spPr>
+        <p:txBody>
+          <a:bodyPr wrap="square" anchor="t">
+            <a:spAutoFit/>
+          </a:bodyPr>
+          <a:lstStyle/>
+          <a:p>
+            <a:pPr>
+              <a:defRPr sz="1400" b="1">
+                <a:solidFill>
+                  <a:srgbClr val="EDF6FF"/>
+                </a:solidFill>
+                <a:latin typeface="Aptos"/>
+              </a:defRPr>
+            </a:pPr>
+            <a:r>
+              <a:t>Evidence traceability</a:t>
+            </a:r>
+          </a:p>
+        </p:txBody>
+      </p:sp>
+      <p:sp>
+        <p:nvSpPr>
+          <p:cNvPr id="20" name="TextBox 19"/>
+          <p:cNvSpPr txBox="1"/>
+          <p:nvPr/>
+        </p:nvSpPr>
+        <p:spPr>
+          <a:xfrm>
+            <a:off x="8302751" y="2916936"/>
+            <a:ext cx="3072384" cy="1097280"/>
+          </a:xfrm>
+          <a:prstGeom prst="rect">
+            <a:avLst/>
+          </a:prstGeom>
+          <a:noFill/>
+        </p:spPr>
+        <p:txBody>
+          <a:bodyPr wrap="square" anchor="t">
+            <a:spAutoFit/>
+          </a:bodyPr>
+          <a:lstStyle/>
+          <a:p>
+            <a:pPr>
+              <a:defRPr sz="1150" b="0">
+                <a:solidFill>
+                  <a:srgbClr val="A4BED6"/>
+                </a:solidFill>
+                <a:latin typeface="Aptos"/>
+              </a:defRPr>
+            </a:pPr>
+            <a:r>
+              <a:t>Decision outputs cite approved knowledge titles, making the RAG layer inspectable by judges.</a:t>
+            </a:r>
+          </a:p>
+        </p:txBody>
+      </p:sp>
+      <p:sp>
+        <p:nvSpPr>
+          <p:cNvPr id="21" name="TextBox 20"/>
+          <p:cNvSpPr txBox="1"/>
+          <p:nvPr/>
+        </p:nvSpPr>
+        <p:spPr>
+          <a:xfrm>
+            <a:off x="658368" y="4782312"/>
+            <a:ext cx="1645920" cy="201168"/>
           </a:xfrm>
           <a:prstGeom prst="rect">
             <a:avLst/>
@@ -10548,41 +11517,41 @@
             <a:pPr>
               <a:defRPr sz="1000" b="1">
                 <a:solidFill>
-                  <a:srgbClr val="22D3EE"/>
+                  <a:srgbClr val="FBBF24"/>
                 </a:solidFill>
                 <a:latin typeface="Courier New"/>
               </a:defRPr>
             </a:pPr>
             <a:r>
-              <a:t>VISION</a:t>
-            </a:r>
-          </a:p>
-        </p:txBody>
-      </p:sp>
-      <p:sp>
-        <p:nvSpPr>
-          <p:cNvPr id="15" name="TextBox 14"/>
-          <p:cNvSpPr txBox="1"/>
-          <p:nvPr/>
-        </p:nvSpPr>
-        <p:spPr>
-          <a:xfrm>
-            <a:off x="7818120" y="2798064"/>
-            <a:ext cx="2743200" cy="1143000"/>
-          </a:xfrm>
-          <a:prstGeom prst="rect">
-            <a:avLst/>
-          </a:prstGeom>
-          <a:noFill/>
-        </p:spPr>
-        <p:txBody>
-          <a:bodyPr wrap="square" anchor="t">
-            <a:spAutoFit/>
-          </a:bodyPr>
-          <a:lstStyle/>
-          <a:p>
-            <a:pPr>
-              <a:defRPr sz="2400" b="1">
+              <a:t>Honest claim</a:t>
+            </a:r>
+          </a:p>
+        </p:txBody>
+      </p:sp>
+      <p:sp>
+        <p:nvSpPr>
+          <p:cNvPr id="22" name="TextBox 21"/>
+          <p:cNvSpPr txBox="1"/>
+          <p:nvPr/>
+        </p:nvSpPr>
+        <p:spPr>
+          <a:xfrm>
+            <a:off x="658368" y="5074920"/>
+            <a:ext cx="10149840" cy="438912"/>
+          </a:xfrm>
+          <a:prstGeom prst="rect">
+            <a:avLst/>
+          </a:prstGeom>
+          <a:noFill/>
+        </p:spPr>
+        <p:txBody>
+          <a:bodyPr wrap="square" anchor="t">
+            <a:spAutoFit/>
+          </a:bodyPr>
+          <a:lstStyle/>
+          <a:p>
+            <a:pPr>
+              <a:defRPr sz="1800" b="1">
                 <a:solidFill>
                   <a:srgbClr val="EDF6FF"/>
                 </a:solidFill>
@@ -10590,58 +11559,14 @@
               </a:defRPr>
             </a:pPr>
             <a:r>
-              <a:t>Inclusive,</a:t>
-            </a:r>
-            <a:br/>
-            <a:r>
-              <a:t>evidence-aware</a:t>
-            </a:r>
-            <a:br/>
-            <a:r>
-              <a:t>brain–heart AI.</a:t>
-            </a:r>
-          </a:p>
-        </p:txBody>
-      </p:sp>
-      <p:sp>
-        <p:nvSpPr>
-          <p:cNvPr id="16" name="TextBox 15"/>
-          <p:cNvSpPr txBox="1"/>
-          <p:nvPr/>
-        </p:nvSpPr>
-        <p:spPr>
-          <a:xfrm>
-            <a:off x="7818120" y="4443984"/>
-            <a:ext cx="2743200" cy="438912"/>
-          </a:xfrm>
-          <a:prstGeom prst="rect">
-            <a:avLst/>
-          </a:prstGeom>
-          <a:noFill/>
-        </p:spPr>
-        <p:txBody>
-          <a:bodyPr wrap="square" anchor="t">
-            <a:spAutoFit/>
-          </a:bodyPr>
-          <a:lstStyle/>
-          <a:p>
-            <a:pPr>
-              <a:defRPr sz="1100" b="1">
-                <a:solidFill>
-                  <a:srgbClr val="5CE1A7"/>
-                </a:solidFill>
-                <a:latin typeface="Aptos"/>
-              </a:defRPr>
-            </a:pPr>
-            <a:r>
-              <a:t>Built in Bangladesh; designed for globally responsible digital-health research.</a:t>
-            </a:r>
-          </a:p>
-        </p:txBody>
-      </p:sp>
-      <p:sp>
-        <p:nvSpPr>
-          <p:cNvPr id="17" name="TextBox 16"/>
+              <a:t>This is a research prototype, not a clinical device. Its strength is a transparent, reproducible workflow—not overstated medical claims.</a:t>
+            </a:r>
+          </a:p>
+        </p:txBody>
+      </p:sp>
+      <p:sp>
+        <p:nvSpPr>
+          <p:cNvPr id="23" name="TextBox 22"/>
           <p:cNvSpPr txBox="1"/>
           <p:nvPr/>
         </p:nvSpPr>
@@ -10677,7 +11602,7 @@
       </p:sp>
       <p:sp>
         <p:nvSpPr>
-          <p:cNvPr id="18" name="TextBox 17"/>
+          <p:cNvPr id="24" name="TextBox 23"/>
           <p:cNvSpPr txBox="1"/>
           <p:nvPr/>
         </p:nvSpPr>

</xml_diff>